<commit_message>
Deck, README and evaluation updated for UP map, transfers, assistant, mobile and messy-page results
Co-Authored-By: Claude Opus 5.5 <noreply@anthropic.com>
</commit_message>
<xml_diff>
--- a/docs/deck/Register-Lens-pitch-deck.pptx
+++ b/docs/deck/Register-Lens-pitch-deck.pptx
@@ -144,7 +144,7 @@
                 </a:solidFill>
                 <a:latin typeface="Calibri"/>
               </a:rPr>
-              <a:t>Cell accuracy by page difficulty (%)</a:t>
+              <a:t>Cell accuracy by page type (%), 22 synthetic pages</a:t>
             </a:r>
           </a:p>
         </c:rich>
@@ -181,13 +181,13 @@
           </c:spPr>
           <c:invertIfNegative val="0"/>
           <c:dLbls>
-            <c:numFmt formatCode="0.0" sourceLinked="0"/>
+            <c:numFmt formatCode="0" sourceLinked="0"/>
             <c:txPr>
               <a:bodyPr/>
               <a:lstStyle/>
               <a:p>
                 <a:pPr>
-                  <a:defRPr b="0" i="0" strike="noStrike" sz="900" u="none">
+                  <a:defRPr b="0" i="0" strike="noStrike" sz="800" u="none">
                     <a:solidFill>
                       <a:srgbClr val="16323A"/>
                     </a:solidFill>
@@ -206,12 +206,12 @@
           </c:dLbls>
           <c:cat>
             <c:multiLvlStrRef>
-              <c:f>Sheet1!$A$2:$A$4</c:f>
+              <c:f>Sheet1!$A$2:$A$5</c:f>
               <c:multiLvlStrCache>
-                <c:ptCount val="3"/>
+                <c:ptCount val="4"/>
                 <c:lvl>
                   <c:pt idx="0">
-                    <c:v>Easy (6 pages)</c:v>
+                    <c:v>Easy (6)</c:v>
                   </c:pt>
                   <c:pt idx="1">
                     <c:v>Medium (4)</c:v>
@@ -219,16 +219,19 @@
                   <c:pt idx="2">
                     <c:v>Hard (2)</c:v>
                   </c:pt>
+                  <c:pt idx="3">
+                    <c:v>Messy (10)</c:v>
+                  </c:pt>
                 </c:lvl>
               </c:multiLvlStrCache>
             </c:multiLvlStrRef>
           </c:cat>
           <c:val>
             <c:numRef>
-              <c:f>Sheet1!$B$2:$B$4</c:f>
+              <c:f>Sheet1!$B$2:$B$5</c:f>
               <c:numCache>
                 <c:formatCode>General</c:formatCode>
-                <c:ptCount val="3"/>
+                <c:ptCount val="4"/>
                 <c:pt idx="0">
                   <c:v>100</c:v>
                 </c:pt>
@@ -237,6 +240,9 @@
                 </c:pt>
                 <c:pt idx="2">
                   <c:v>100</c:v>
+                </c:pt>
+                <c:pt idx="3">
+                  <c:v>92.9</c:v>
                 </c:pt>
               </c:numCache>
             </c:numRef>
@@ -264,13 +270,13 @@
           </c:spPr>
           <c:invertIfNegative val="0"/>
           <c:dLbls>
-            <c:numFmt formatCode="0.0" sourceLinked="0"/>
+            <c:numFmt formatCode="0" sourceLinked="0"/>
             <c:txPr>
               <a:bodyPr/>
               <a:lstStyle/>
               <a:p>
                 <a:pPr>
-                  <a:defRPr b="0" i="0" strike="noStrike" sz="900" u="none">
+                  <a:defRPr b="0" i="0" strike="noStrike" sz="800" u="none">
                     <a:solidFill>
                       <a:srgbClr val="16323A"/>
                     </a:solidFill>
@@ -289,12 +295,12 @@
           </c:dLbls>
           <c:cat>
             <c:multiLvlStrRef>
-              <c:f>Sheet1!$A$2:$A$4</c:f>
+              <c:f>Sheet1!$A$2:$A$5</c:f>
               <c:multiLvlStrCache>
-                <c:ptCount val="3"/>
+                <c:ptCount val="4"/>
                 <c:lvl>
                   <c:pt idx="0">
-                    <c:v>Easy (6 pages)</c:v>
+                    <c:v>Easy (6)</c:v>
                   </c:pt>
                   <c:pt idx="1">
                     <c:v>Medium (4)</c:v>
@@ -302,16 +308,19 @@
                   <c:pt idx="2">
                     <c:v>Hard (2)</c:v>
                   </c:pt>
+                  <c:pt idx="3">
+                    <c:v>Messy (10)</c:v>
+                  </c:pt>
                 </c:lvl>
               </c:multiLvlStrCache>
             </c:multiLvlStrRef>
           </c:cat>
           <c:val>
             <c:numRef>
-              <c:f>Sheet1!$C$2:$C$4</c:f>
+              <c:f>Sheet1!$C$2:$C$5</c:f>
               <c:numCache>
                 <c:formatCode>General</c:formatCode>
-                <c:ptCount val="3"/>
+                <c:ptCount val="4"/>
                 <c:pt idx="0">
                   <c:v>100</c:v>
                 </c:pt>
@@ -320,6 +329,9 @@
                 </c:pt>
                 <c:pt idx="2">
                   <c:v>89.3</c:v>
+                </c:pt>
+                <c:pt idx="3">
+                  <c:v>51.4</c:v>
                 </c:pt>
               </c:numCache>
             </c:numRef>
@@ -347,13 +359,13 @@
           </c:spPr>
           <c:invertIfNegative val="0"/>
           <c:dLbls>
-            <c:numFmt formatCode="0.0" sourceLinked="0"/>
+            <c:numFmt formatCode="0" sourceLinked="0"/>
             <c:txPr>
               <a:bodyPr/>
               <a:lstStyle/>
               <a:p>
                 <a:pPr>
-                  <a:defRPr b="0" i="0" strike="noStrike" sz="900" u="none">
+                  <a:defRPr b="0" i="0" strike="noStrike" sz="800" u="none">
                     <a:solidFill>
                       <a:srgbClr val="16323A"/>
                     </a:solidFill>
@@ -372,12 +384,12 @@
           </c:dLbls>
           <c:cat>
             <c:multiLvlStrRef>
-              <c:f>Sheet1!$A$2:$A$4</c:f>
+              <c:f>Sheet1!$A$2:$A$5</c:f>
               <c:multiLvlStrCache>
-                <c:ptCount val="3"/>
+                <c:ptCount val="4"/>
                 <c:lvl>
                   <c:pt idx="0">
-                    <c:v>Easy (6 pages)</c:v>
+                    <c:v>Easy (6)</c:v>
                   </c:pt>
                   <c:pt idx="1">
                     <c:v>Medium (4)</c:v>
@@ -385,16 +397,19 @@
                   <c:pt idx="2">
                     <c:v>Hard (2)</c:v>
                   </c:pt>
+                  <c:pt idx="3">
+                    <c:v>Messy (10)</c:v>
+                  </c:pt>
                 </c:lvl>
               </c:multiLvlStrCache>
             </c:multiLvlStrRef>
           </c:cat>
           <c:val>
             <c:numRef>
-              <c:f>Sheet1!$D$2:$D$4</c:f>
+              <c:f>Sheet1!$D$2:$D$5</c:f>
               <c:numCache>
                 <c:formatCode>General</c:formatCode>
-                <c:ptCount val="3"/>
+                <c:ptCount val="4"/>
                 <c:pt idx="0">
                   <c:v>100</c:v>
                 </c:pt>
@@ -404,18 +419,21 @@
                 <c:pt idx="2">
                   <c:v>85.7</c:v>
                 </c:pt>
+                <c:pt idx="3">
+                  <c:v>73.4</c:v>
+                </c:pt>
               </c:numCache>
             </c:numRef>
           </c:val>
         </c:ser>
         <c:dLbls>
-          <c:numFmt formatCode="0.0" sourceLinked="0"/>
+          <c:numFmt formatCode="0" sourceLinked="0"/>
           <c:txPr>
             <a:bodyPr/>
             <a:lstStyle/>
             <a:p>
               <a:pPr>
-                <a:defRPr b="0" i="0" strike="noStrike" sz="900" u="none">
+                <a:defRPr b="0" i="0" strike="noStrike" sz="800" u="none">
                   <a:solidFill>
                     <a:srgbClr val="16323A"/>
                   </a:solidFill>
@@ -1409,7 +1427,7 @@
           <a:p>
             <a:r>
               <a:rPr lang="en-US" dirty="0"/>
-              <a:t>Three people. The pharmacist who double-enters. The district officer who plans from an untrustworthy screen. And the patient who finds the shelf empty. Our wedge is the end-of-day moment when the register is on the desk and DVDMS is still not updated.</a:t>
+              <a:t>We scaled from one district to the whole state. These are real facility locations from OpenStreetMap: 3,948 public facilities across 75 districts. For facilities that have not scanned a register the stock is simulated, and we say so on screen. Phase 3 is live: the app finds medicine that will expire before it can be used and suggests moving it to a nearby facility that is running short, with the district officer approving every move.</a:t>
             </a:r>
             <a:endParaRPr lang="en-US" dirty="0"/>
           </a:p>
@@ -1761,7 +1779,7 @@
           <a:p>
             <a:r>
               <a:rPr lang="en-US" dirty="0"/>
-              <a:t>These numbers are from 12 synthetic pages, 168 lines, checked cell by cell against an answer key. Quantities, which drive the stock-out numbers, were perfect. All seven misses were single-digit errors in batch or expiry on the two hardest pages, and the model was equally confident on them, so we added a cross-check against the batches DVDMS already lists. We are upfront that the demo DVDMS is a mock, so this demonstrates the mechanism.</a:t>
+              <a:t>We measured honestly on 22 synthetic pages, including 10 deliberately messy ones. Medicine names were always right. Quantities stayed above 90 percent even on messy pages. The weak spot is small cursive batch codes and expiry dates, and the model does not know when it is wrong, so we cross-check against the batches DVDMS already has and the balance of each line. That flagged 63 of the 74 lines that had any error. Every line is confirmed by the pharmacist before anything is used.</a:t>
             </a:r>
             <a:endParaRPr lang="en-US" dirty="0"/>
           </a:p>
@@ -1849,7 +1867,7 @@
           <a:p>
             <a:r>
               <a:rPr lang="en-US" dirty="0"/>
-              <a:t>Our failure contract. A wrong reading costs the pharmacist a tap, not a wrong stock number in the system. Nothing goes to DVDMS automatically.</a:t>
+              <a:t>Two features for real users. The assistant is Gemini with five tools over the app's data; here it answered a Hindi question about Barabanki by calling the district tool. And the whole app installs on a pharmacist's phone from the browser, with the camera for scanning. Every step keeps a human in charge.</a:t>
             </a:r>
             <a:endParaRPr lang="en-US" dirty="0"/>
           </a:p>
@@ -2733,7 +2751,7 @@
                 <a:ea typeface="Calibri" pitchFamily="34" charset="-122"/>
                 <a:cs typeface="Calibri" pitchFamily="34" charset="-120"/>
               </a:rPr>
-              <a:t>Phase 2: alerts and screens in the PHC's state language.</a:t>
+              <a:t>Phase 2, live: district alerts in 16 Indian languages; UP defaults to Hindi, Urdu, English.</a:t>
             </a:r>
             <a:endParaRPr lang="en-US" sz="1200" dirty="0"/>
           </a:p>
@@ -2772,7 +2790,7 @@
                 <a:ea typeface="Nirmala UI" pitchFamily="34" charset="-122"/>
                 <a:cs typeface="Nirmala UI" pitchFamily="34" charset="-120"/>
               </a:rPr>
-              <a:t>தமிழ்  తెలుగు  বাংলা  मराठी  ଓଡ଼ିଆ  ಕನ್ನಡ  ગુજરાતી  മലയാളം  ਪੰਜਾਬੀ</a:t>
+              <a:t>हिन्दी  اردو  भोजपुरी  தமிழ்  తెలుగు  বাংলা  मराठी  ଓଡ଼ିଆ  ಕನ್ನಡ</a:t>
             </a:r>
             <a:endParaRPr lang="en-US" sz="1000" dirty="0"/>
           </a:p>
@@ -3197,7 +3215,7 @@
                 <a:ea typeface="Calibri" pitchFamily="34" charset="-122"/>
                 <a:cs typeface="Calibri" pitchFamily="34" charset="-120"/>
               </a:rPr>
-              <a:t>Phase 3: expiry redistribution. </a:t>
+              <a:t>Already statewide: </a:t>
             </a:r>
             <a:pPr indent="0" marL="0">
               <a:buNone/>
@@ -3211,7 +3229,7 @@
                 <a:ea typeface="Calibri" pitchFamily="34" charset="-122"/>
                 <a:cs typeface="Calibri" pitchFamily="34" charset="-120"/>
               </a:rPr>
-              <a:t>Batches close to expiry are routed to the nearby clinic or store that urgently needs them, with the district officer approving every move.</a:t>
+              <a:t>3,948 facilities in all 75 UP districts are on the map today. A new state needs its facility list, register template and languages, not new code.</a:t>
             </a:r>
             <a:endParaRPr lang="en-US" sz="1300" dirty="0"/>
           </a:p>
@@ -3675,7 +3693,7 @@
                           <a:ea typeface="Calibri" pitchFamily="34" charset="-122"/>
                           <a:cs typeface="Calibri" pitchFamily="34" charset="-120"/>
                         </a:rPr>
-                        <a:t>Gemini reads handwriting to JSON, model failover, OpenCV clean-up, evaluation script and results</a:t>
+                        <a:t>Gemini reads handwriting to JSON; function-calling assistant; multilingual alerts; OpenCV clean-up; 22-page evaluation</a:t>
                       </a:r>
                       <a:endParaRPr lang="en-US" sz="1150" dirty="0">
                         <a:latin typeface="Calibri" charset="0"/>
@@ -4087,7 +4105,7 @@
                           <a:ea typeface="Calibri" pitchFamily="34" charset="-122"/>
                           <a:cs typeface="Calibri" pitchFamily="34" charset="-120"/>
                         </a:rPr>
-                        <a:t>Language, register template and medicine catalogue as separate configs; Phase 2 languages</a:t>
+                        <a:t>All 75 UP districts, 3,948 facilities, villages far from care; 16 languages; config-driven for other states</a:t>
                       </a:r>
                       <a:endParaRPr lang="en-US" sz="1150" dirty="0">
                         <a:latin typeface="Calibri" charset="0"/>
@@ -4293,7 +4311,7 @@
                           <a:ea typeface="Calibri" pitchFamily="34" charset="-122"/>
                           <a:cs typeface="Calibri" pitchFamily="34" charset="-120"/>
                         </a:rPr>
-                        <a:t>No new hardware; DVDMS bulk-entry output; four-week pilot plan; Dockerfile for Cloud Run</a:t>
+                        <a:t>Runs on Cloud Run; installable phone app; DVDMS bulk-entry output; four-week pilot plan</a:t>
                       </a:r>
                       <a:endParaRPr lang="en-US" sz="1150" dirty="0">
                         <a:latin typeface="Calibri" charset="0"/>
@@ -4499,7 +4517,7 @@
                           <a:ea typeface="Calibri" pitchFamily="34" charset="-122"/>
                           <a:cs typeface="Calibri" pitchFamily="34" charset="-120"/>
                         </a:rPr>
-                        <a:t>Attacks the stock-out and expiry-loss cycle at the source; reported losses in crores</a:t>
+                        <a:t>Stock-outs and expiry losses (reported in crores) at the source; expiry transfers with officer approval</a:t>
                       </a:r>
                       <a:endParaRPr lang="en-US" sz="1150" dirty="0">
                         <a:latin typeface="Calibri" charset="0"/>
@@ -5368,26 +5386,96 @@
                 <a:ea typeface="Cambria" pitchFamily="34" charset="-122"/>
                 <a:cs typeface="Cambria" pitchFamily="34" charset="-120"/>
               </a:rPr>
-              <a:t>Three people pay for the gap</a:t>
+              <a:t>Beyond one PHC: all of Uttar Pradesh</a:t>
             </a:r>
             <a:endParaRPr lang="en-US" sz="3000" dirty="0"/>
           </a:p>
         </p:txBody>
       </p:sp>
-      <p:sp>
-        <p:nvSpPr>
-          <p:cNvPr id="3" name="Shape 1"/>
+      <p:pic>
+        <p:nvPicPr>
+          <p:cNvPr id="3" name="Image 0" descr="D:\RegisterLens\docs\deck\img_crop\map_district.png">    </p:cNvPr>
+          <p:cNvPicPr>
+            <a:picLocks noChangeAspect="1"/>
+          </p:cNvPicPr>
+          <p:nvPr/>
+        </p:nvPicPr>
+        <p:blipFill>
+          <a:blip r:embed="rId1"/>
+          <a:stretch>
+            <a:fillRect/>
+          </a:stretch>
+        </p:blipFill>
+        <p:spPr>
+          <a:xfrm>
+            <a:off x="457200" y="1188720"/>
+            <a:ext cx="4754880" cy="2130552"/>
+          </a:xfrm>
+          <a:prstGeom prst="rect">
+            <a:avLst/>
+          </a:prstGeom>
+          <a:effectLst>
+            <a:outerShdw sx="100000" sy="100000" kx="0" ky="0" algn="bl" rotWithShape="0" blurRad="127000" dist="38100" dir="5400000">
+              <a:srgbClr val="14665C">
+                <a:alpha val="18000"/>
+              </a:srgbClr>
+            </a:outerShdw>
+          </a:effectLst>
+        </p:spPr>
+      </p:pic>
+      <p:sp>
+        <p:nvSpPr>
+          <p:cNvPr id="4" name="Text 1"/>
+          <p:cNvSpPr txBox="1"/>
+          <p:nvPr/>
+        </p:nvSpPr>
+        <p:spPr>
+          <a:xfrm>
+            <a:off x="457200" y="3383280"/>
+            <a:ext cx="4754880" cy="457200"/>
+          </a:xfrm>
+          <a:prstGeom prst="rect">
+            <a:avLst/>
+          </a:prstGeom>
+          <a:noFill/>
+          <a:ln/>
+        </p:spPr>
+        <p:txBody>
+          <a:bodyPr wrap="square" lIns="0" tIns="0" rIns="0" bIns="0" rtlCol="0" anchor="t"/>
+          <a:lstStyle/>
+          <a:p>
+            <a:pPr indent="0" marL="0">
+              <a:buNone/>
+            </a:pPr>
+            <a:r>
+              <a:rPr lang="en-US" sz="1100" dirty="0">
+                <a:solidFill>
+                  <a:srgbClr val="5B7780"/>
+                </a:solidFill>
+                <a:latin typeface="Calibri" pitchFamily="34" charset="0"/>
+                <a:ea typeface="Calibri" pitchFamily="34" charset="-122"/>
+                <a:cs typeface="Calibri" pitchFamily="34" charset="-120"/>
+              </a:rPr>
+              <a:t>Barabanki: every DH, CHC, PHC and Health &amp; Wellness Centre at its real location, coloured by stock risk</a:t>
+            </a:r>
+            <a:endParaRPr lang="en-US" sz="1100" dirty="0"/>
+          </a:p>
+        </p:txBody>
+      </p:sp>
+      <p:sp>
+        <p:nvSpPr>
+          <p:cNvPr id="5" name="Shape 2"/>
           <p:cNvSpPr/>
           <p:nvPr/>
         </p:nvSpPr>
         <p:spPr>
           <a:xfrm>
-            <a:off x="457200" y="1371600"/>
-            <a:ext cx="2606040" cy="2651760"/>
+            <a:off x="5486400" y="1188720"/>
+            <a:ext cx="3246120" cy="804672"/>
           </a:xfrm>
           <a:prstGeom prst="roundRect">
             <a:avLst>
-              <a:gd name="adj" fmla="val 4211"/>
+              <a:gd name="adj" fmla="val 13636"/>
             </a:avLst>
           </a:prstGeom>
           <a:solidFill>
@@ -5410,39 +5498,14 @@
       </p:sp>
       <p:sp>
         <p:nvSpPr>
-          <p:cNvPr id="4" name="Shape 2"/>
-          <p:cNvSpPr/>
-          <p:nvPr/>
-        </p:nvSpPr>
-        <p:spPr>
-          <a:xfrm>
-            <a:off x="685800" y="1600200"/>
-            <a:ext cx="548640" cy="548640"/>
-          </a:xfrm>
-          <a:prstGeom prst="ellipse">
-            <a:avLst/>
-          </a:prstGeom>
-          <a:solidFill>
-            <a:srgbClr val="167F71"/>
-          </a:solidFill>
-          <a:ln w="12700">
-            <a:solidFill>
-              <a:srgbClr val="167F71"/>
-            </a:solidFill>
-            <a:prstDash val="solid"/>
-          </a:ln>
-        </p:spPr>
-      </p:sp>
-      <p:sp>
-        <p:nvSpPr>
-          <p:cNvPr id="5" name="Text 3"/>
+          <p:cNvPr id="6" name="Text 3"/>
           <p:cNvSpPr txBox="1"/>
           <p:nvPr/>
         </p:nvSpPr>
         <p:spPr>
           <a:xfrm>
-            <a:off x="685800" y="1600200"/>
-            <a:ext cx="548640" cy="548640"/>
+            <a:off x="5669280" y="1188720"/>
+            <a:ext cx="2971800" cy="804672"/>
           </a:xfrm>
           <a:prstGeom prst="rect">
             <a:avLst/>
@@ -5454,89 +5517,25 @@
           <a:bodyPr wrap="square" lIns="0" tIns="0" rIns="0" bIns="0" rtlCol="0" anchor="ctr"/>
           <a:lstStyle/>
           <a:p>
-            <a:pPr algn="ctr" indent="0" marL="0">
-              <a:buNone/>
-            </a:pPr>
-            <a:r>
-              <a:rPr lang="en-US" sz="1600" b="1" dirty="0">
-                <a:solidFill>
-                  <a:srgbClr val="FFFFFF"/>
+            <a:pPr indent="0" marL="0">
+              <a:buNone/>
+            </a:pPr>
+            <a:r>
+              <a:rPr lang="en-US" sz="2400" b="1" dirty="0">
+                <a:solidFill>
+                  <a:srgbClr val="167F71"/>
                 </a:solidFill>
                 <a:latin typeface="Cambria" pitchFamily="34" charset="0"/>
                 <a:ea typeface="Cambria" pitchFamily="34" charset="-122"/>
                 <a:cs typeface="Cambria" pitchFamily="34" charset="-120"/>
               </a:rPr>
-              <a:t>1</a:t>
-            </a:r>
-            <a:endParaRPr lang="en-US" sz="1600" dirty="0"/>
-          </a:p>
-        </p:txBody>
-      </p:sp>
-      <p:sp>
-        <p:nvSpPr>
-          <p:cNvPr id="6" name="Text 4"/>
-          <p:cNvSpPr txBox="1"/>
-          <p:nvPr/>
-        </p:nvSpPr>
-        <p:spPr>
-          <a:xfrm>
-            <a:off x="685800" y="2286000"/>
-            <a:ext cx="2194560" cy="548640"/>
-          </a:xfrm>
-          <a:prstGeom prst="rect">
-            <a:avLst/>
-          </a:prstGeom>
-          <a:noFill/>
-          <a:ln/>
-        </p:spPr>
-        <p:txBody>
-          <a:bodyPr wrap="square" lIns="0" tIns="0" rIns="0" bIns="0" rtlCol="0" anchor="t"/>
-          <a:lstStyle/>
-          <a:p>
-            <a:pPr indent="0" marL="0">
-              <a:buNone/>
-            </a:pPr>
-            <a:r>
-              <a:rPr lang="en-US" sz="1700" b="1" dirty="0">
-                <a:solidFill>
-                  <a:srgbClr val="16323A"/>
-                </a:solidFill>
-                <a:latin typeface="Cambria" pitchFamily="34" charset="0"/>
-                <a:ea typeface="Cambria" pitchFamily="34" charset="-122"/>
-                <a:cs typeface="Cambria" pitchFamily="34" charset="-120"/>
-              </a:rPr>
-              <a:t>PHC pharmacist</a:t>
-            </a:r>
-            <a:endParaRPr lang="en-US" sz="1700" dirty="0"/>
-          </a:p>
-        </p:txBody>
-      </p:sp>
-      <p:sp>
-        <p:nvSpPr>
-          <p:cNvPr id="7" name="Text 5"/>
-          <p:cNvSpPr txBox="1"/>
-          <p:nvPr/>
-        </p:nvSpPr>
-        <p:spPr>
-          <a:xfrm>
-            <a:off x="685800" y="2880360"/>
-            <a:ext cx="2194560" cy="1051560"/>
-          </a:xfrm>
-          <a:prstGeom prst="rect">
-            <a:avLst/>
-          </a:prstGeom>
-          <a:noFill/>
-          <a:ln/>
-        </p:spPr>
-        <p:txBody>
-          <a:bodyPr wrap="square" lIns="0" tIns="0" rIns="0" bIns="0" rtlCol="0" anchor="t"/>
-          <a:lstStyle/>
-          <a:p>
-            <a:pPr indent="0" marL="0">
-              <a:buNone/>
-            </a:pPr>
-            <a:r>
-              <a:rPr lang="en-US" sz="1300" dirty="0">
+              <a:t>3,948  </a:t>
+            </a:r>
+            <a:pPr indent="0" marL="0">
+              <a:buNone/>
+            </a:pPr>
+            <a:r>
+              <a:rPr lang="en-US" sz="1150" dirty="0">
                 <a:solidFill>
                   <a:srgbClr val="5B7780"/>
                 </a:solidFill>
@@ -5544,26 +5543,26 @@
                 <a:ea typeface="Calibri" pitchFamily="34" charset="-122"/>
                 <a:cs typeface="Calibri" pitchFamily="34" charset="-120"/>
               </a:rPr>
-              <a:t>Copies the day's register into DVDMS every evening, or does not, and the numbers drift.</a:t>
-            </a:r>
-            <a:endParaRPr lang="en-US" sz="1300" dirty="0"/>
-          </a:p>
-        </p:txBody>
-      </p:sp>
-      <p:sp>
-        <p:nvSpPr>
-          <p:cNvPr id="8" name="Shape 6"/>
+              <a:t>public health facilities mapped (OpenStreetMap)</a:t>
+            </a:r>
+            <a:endParaRPr lang="en-US" sz="2400" dirty="0"/>
+          </a:p>
+        </p:txBody>
+      </p:sp>
+      <p:sp>
+        <p:nvSpPr>
+          <p:cNvPr id="7" name="Shape 4"/>
           <p:cNvSpPr/>
           <p:nvPr/>
         </p:nvSpPr>
         <p:spPr>
           <a:xfrm>
-            <a:off x="3246120" y="1371600"/>
-            <a:ext cx="2606040" cy="2651760"/>
+            <a:off x="5486400" y="2121408"/>
+            <a:ext cx="3246120" cy="804672"/>
           </a:xfrm>
           <a:prstGeom prst="roundRect">
             <a:avLst>
-              <a:gd name="adj" fmla="val 4211"/>
+              <a:gd name="adj" fmla="val 13636"/>
             </a:avLst>
           </a:prstGeom>
           <a:solidFill>
@@ -5586,39 +5585,14 @@
       </p:sp>
       <p:sp>
         <p:nvSpPr>
-          <p:cNvPr id="9" name="Shape 7"/>
-          <p:cNvSpPr/>
-          <p:nvPr/>
-        </p:nvSpPr>
-        <p:spPr>
-          <a:xfrm>
-            <a:off x="3474720" y="1600200"/>
-            <a:ext cx="548640" cy="548640"/>
-          </a:xfrm>
-          <a:prstGeom prst="ellipse">
-            <a:avLst/>
-          </a:prstGeom>
-          <a:solidFill>
-            <a:srgbClr val="3B9CE2"/>
-          </a:solidFill>
-          <a:ln w="12700">
-            <a:solidFill>
-              <a:srgbClr val="3B9CE2"/>
-            </a:solidFill>
-            <a:prstDash val="solid"/>
-          </a:ln>
-        </p:spPr>
-      </p:sp>
-      <p:sp>
-        <p:nvSpPr>
-          <p:cNvPr id="10" name="Text 8"/>
+          <p:cNvPr id="8" name="Text 5"/>
           <p:cNvSpPr txBox="1"/>
           <p:nvPr/>
         </p:nvSpPr>
         <p:spPr>
           <a:xfrm>
-            <a:off x="3474720" y="1600200"/>
-            <a:ext cx="548640" cy="548640"/>
+            <a:off x="5669280" y="2121408"/>
+            <a:ext cx="2971800" cy="804672"/>
           </a:xfrm>
           <a:prstGeom prst="rect">
             <a:avLst/>
@@ -5630,89 +5604,25 @@
           <a:bodyPr wrap="square" lIns="0" tIns="0" rIns="0" bIns="0" rtlCol="0" anchor="ctr"/>
           <a:lstStyle/>
           <a:p>
-            <a:pPr algn="ctr" indent="0" marL="0">
-              <a:buNone/>
-            </a:pPr>
-            <a:r>
-              <a:rPr lang="en-US" sz="1600" b="1" dirty="0">
-                <a:solidFill>
-                  <a:srgbClr val="FFFFFF"/>
+            <a:pPr indent="0" marL="0">
+              <a:buNone/>
+            </a:pPr>
+            <a:r>
+              <a:rPr lang="en-US" sz="2400" b="1" dirty="0">
+                <a:solidFill>
+                  <a:srgbClr val="167F71"/>
                 </a:solidFill>
                 <a:latin typeface="Cambria" pitchFamily="34" charset="0"/>
                 <a:ea typeface="Cambria" pitchFamily="34" charset="-122"/>
                 <a:cs typeface="Cambria" pitchFamily="34" charset="-120"/>
               </a:rPr>
-              <a:t>2</a:t>
-            </a:r>
-            <a:endParaRPr lang="en-US" sz="1600" dirty="0"/>
-          </a:p>
-        </p:txBody>
-      </p:sp>
-      <p:sp>
-        <p:nvSpPr>
-          <p:cNvPr id="11" name="Text 9"/>
-          <p:cNvSpPr txBox="1"/>
-          <p:nvPr/>
-        </p:nvSpPr>
-        <p:spPr>
-          <a:xfrm>
-            <a:off x="3474720" y="2286000"/>
-            <a:ext cx="2194560" cy="548640"/>
-          </a:xfrm>
-          <a:prstGeom prst="rect">
-            <a:avLst/>
-          </a:prstGeom>
-          <a:noFill/>
-          <a:ln/>
-        </p:spPr>
-        <p:txBody>
-          <a:bodyPr wrap="square" lIns="0" tIns="0" rIns="0" bIns="0" rtlCol="0" anchor="t"/>
-          <a:lstStyle/>
-          <a:p>
-            <a:pPr indent="0" marL="0">
-              <a:buNone/>
-            </a:pPr>
-            <a:r>
-              <a:rPr lang="en-US" sz="1700" b="1" dirty="0">
-                <a:solidFill>
-                  <a:srgbClr val="16323A"/>
-                </a:solidFill>
-                <a:latin typeface="Cambria" pitchFamily="34" charset="0"/>
-                <a:ea typeface="Cambria" pitchFamily="34" charset="-122"/>
-                <a:cs typeface="Cambria" pitchFamily="34" charset="-120"/>
-              </a:rPr>
-              <a:t>District drug store officer</a:t>
-            </a:r>
-            <a:endParaRPr lang="en-US" sz="1700" dirty="0"/>
-          </a:p>
-        </p:txBody>
-      </p:sp>
-      <p:sp>
-        <p:nvSpPr>
-          <p:cNvPr id="12" name="Text 10"/>
-          <p:cNvSpPr txBox="1"/>
-          <p:nvPr/>
-        </p:nvSpPr>
-        <p:spPr>
-          <a:xfrm>
-            <a:off x="3474720" y="2880360"/>
-            <a:ext cx="2194560" cy="1051560"/>
-          </a:xfrm>
-          <a:prstGeom prst="rect">
-            <a:avLst/>
-          </a:prstGeom>
-          <a:noFill/>
-          <a:ln/>
-        </p:spPr>
-        <p:txBody>
-          <a:bodyPr wrap="square" lIns="0" tIns="0" rIns="0" bIns="0" rtlCol="0" anchor="t"/>
-          <a:lstStyle/>
-          <a:p>
-            <a:pPr indent="0" marL="0">
-              <a:buNone/>
-            </a:pPr>
-            <a:r>
-              <a:rPr lang="en-US" sz="1300" dirty="0">
+              <a:t>75  </a:t>
+            </a:r>
+            <a:pPr indent="0" marL="0">
+              <a:buNone/>
+            </a:pPr>
+            <a:r>
+              <a:rPr lang="en-US" sz="1150" dirty="0">
                 <a:solidFill>
                   <a:srgbClr val="5B7780"/>
                 </a:solidFill>
@@ -5720,26 +5630,26 @@
                 <a:ea typeface="Calibri" pitchFamily="34" charset="-122"/>
                 <a:cs typeface="Calibri" pitchFamily="34" charset="-120"/>
               </a:rPr>
-              <a:t>Plans indents from a screen that says 40 days of stock when the shelf says 6.</a:t>
-            </a:r>
-            <a:endParaRPr lang="en-US" sz="1300" dirty="0"/>
-          </a:p>
-        </p:txBody>
-      </p:sp>
-      <p:sp>
-        <p:nvSpPr>
-          <p:cNvPr id="13" name="Shape 11"/>
+              <a:t>districts, with villages far from care</a:t>
+            </a:r>
+            <a:endParaRPr lang="en-US" sz="2400" dirty="0"/>
+          </a:p>
+        </p:txBody>
+      </p:sp>
+      <p:sp>
+        <p:nvSpPr>
+          <p:cNvPr id="9" name="Shape 6"/>
           <p:cNvSpPr/>
           <p:nvPr/>
         </p:nvSpPr>
         <p:spPr>
           <a:xfrm>
-            <a:off x="6035040" y="1371600"/>
-            <a:ext cx="2606040" cy="2651760"/>
+            <a:off x="5486400" y="3054096"/>
+            <a:ext cx="3246120" cy="804672"/>
           </a:xfrm>
           <a:prstGeom prst="roundRect">
             <a:avLst>
-              <a:gd name="adj" fmla="val 4211"/>
+              <a:gd name="adj" fmla="val 13636"/>
             </a:avLst>
           </a:prstGeom>
           <a:solidFill>
@@ -5762,39 +5672,14 @@
       </p:sp>
       <p:sp>
         <p:nvSpPr>
-          <p:cNvPr id="14" name="Shape 12"/>
-          <p:cNvSpPr/>
-          <p:nvPr/>
-        </p:nvSpPr>
-        <p:spPr>
-          <a:xfrm>
-            <a:off x="6263640" y="1600200"/>
-            <a:ext cx="548640" cy="548640"/>
-          </a:xfrm>
-          <a:prstGeom prst="ellipse">
-            <a:avLst/>
-          </a:prstGeom>
-          <a:solidFill>
-            <a:srgbClr val="F0A23B"/>
-          </a:solidFill>
-          <a:ln w="12700">
-            <a:solidFill>
-              <a:srgbClr val="F0A23B"/>
-            </a:solidFill>
-            <a:prstDash val="solid"/>
-          </a:ln>
-        </p:spPr>
-      </p:sp>
-      <p:sp>
-        <p:nvSpPr>
-          <p:cNvPr id="15" name="Text 13"/>
+          <p:cNvPr id="10" name="Text 7"/>
           <p:cNvSpPr txBox="1"/>
           <p:nvPr/>
         </p:nvSpPr>
         <p:spPr>
           <a:xfrm>
-            <a:off x="6263640" y="1600200"/>
-            <a:ext cx="548640" cy="548640"/>
+            <a:off x="5669280" y="3054096"/>
+            <a:ext cx="2971800" cy="804672"/>
           </a:xfrm>
           <a:prstGeom prst="rect">
             <a:avLst/>
@@ -5806,89 +5691,25 @@
           <a:bodyPr wrap="square" lIns="0" tIns="0" rIns="0" bIns="0" rtlCol="0" anchor="ctr"/>
           <a:lstStyle/>
           <a:p>
-            <a:pPr algn="ctr" indent="0" marL="0">
-              <a:buNone/>
-            </a:pPr>
-            <a:r>
-              <a:rPr lang="en-US" sz="1600" b="1" dirty="0">
-                <a:solidFill>
-                  <a:srgbClr val="FFFFFF"/>
+            <a:pPr indent="0" marL="0">
+              <a:buNone/>
+            </a:pPr>
+            <a:r>
+              <a:rPr lang="en-US" sz="2400" b="1" dirty="0">
+                <a:solidFill>
+                  <a:srgbClr val="167F71"/>
                 </a:solidFill>
                 <a:latin typeface="Cambria" pitchFamily="34" charset="0"/>
                 <a:ea typeface="Cambria" pitchFamily="34" charset="-122"/>
                 <a:cs typeface="Cambria" pitchFamily="34" charset="-120"/>
               </a:rPr>
-              <a:t>3</a:t>
-            </a:r>
-            <a:endParaRPr lang="en-US" sz="1600" dirty="0"/>
-          </a:p>
-        </p:txBody>
-      </p:sp>
-      <p:sp>
-        <p:nvSpPr>
-          <p:cNvPr id="16" name="Text 14"/>
-          <p:cNvSpPr txBox="1"/>
-          <p:nvPr/>
-        </p:nvSpPr>
-        <p:spPr>
-          <a:xfrm>
-            <a:off x="6263640" y="2286000"/>
-            <a:ext cx="2194560" cy="548640"/>
-          </a:xfrm>
-          <a:prstGeom prst="rect">
-            <a:avLst/>
-          </a:prstGeom>
-          <a:noFill/>
-          <a:ln/>
-        </p:spPr>
-        <p:txBody>
-          <a:bodyPr wrap="square" lIns="0" tIns="0" rIns="0" bIns="0" rtlCol="0" anchor="t"/>
-          <a:lstStyle/>
-          <a:p>
-            <a:pPr indent="0" marL="0">
-              <a:buNone/>
-            </a:pPr>
-            <a:r>
-              <a:rPr lang="en-US" sz="1700" b="1" dirty="0">
-                <a:solidFill>
-                  <a:srgbClr val="16323A"/>
-                </a:solidFill>
-                <a:latin typeface="Cambria" pitchFamily="34" charset="0"/>
-                <a:ea typeface="Cambria" pitchFamily="34" charset="-122"/>
-                <a:cs typeface="Cambria" pitchFamily="34" charset="-120"/>
-              </a:rPr>
-              <a:t>The patient</a:t>
-            </a:r>
-            <a:endParaRPr lang="en-US" sz="1700" dirty="0"/>
-          </a:p>
-        </p:txBody>
-      </p:sp>
-      <p:sp>
-        <p:nvSpPr>
-          <p:cNvPr id="17" name="Text 15"/>
-          <p:cNvSpPr txBox="1"/>
-          <p:nvPr/>
-        </p:nvSpPr>
-        <p:spPr>
-          <a:xfrm>
-            <a:off x="6263640" y="2880360"/>
-            <a:ext cx="2194560" cy="1051560"/>
-          </a:xfrm>
-          <a:prstGeom prst="rect">
-            <a:avLst/>
-          </a:prstGeom>
-          <a:noFill/>
-          <a:ln/>
-        </p:spPr>
-        <p:txBody>
-          <a:bodyPr wrap="square" lIns="0" tIns="0" rIns="0" bIns="0" rtlCol="0" anchor="t"/>
-          <a:lstStyle/>
-          <a:p>
-            <a:pPr indent="0" marL="0">
-              <a:buNone/>
-            </a:pPr>
-            <a:r>
-              <a:rPr lang="en-US" sz="1300" dirty="0">
+              <a:t>84  </a:t>
+            </a:r>
+            <a:pPr indent="0" marL="0">
+              <a:buNone/>
+            </a:pPr>
+            <a:r>
+              <a:rPr lang="en-US" sz="1150" dirty="0">
                 <a:solidFill>
                   <a:srgbClr val="5B7780"/>
                 </a:solidFill>
@@ -5896,22 +5717,22 @@
                 <a:ea typeface="Calibri" pitchFamily="34" charset="-122"/>
                 <a:cs typeface="Calibri" pitchFamily="34" charset="-120"/>
               </a:rPr>
-              <a:t>Walks in for ORS or a BP tablet and hears it is out of stock.</a:t>
-            </a:r>
-            <a:endParaRPr lang="en-US" sz="1300" dirty="0"/>
-          </a:p>
-        </p:txBody>
-      </p:sp>
-      <p:sp>
-        <p:nvSpPr>
-          <p:cNvPr id="18" name="Text 16"/>
+              <a:t>expiry transfers suggested in Barabanki alone</a:t>
+            </a:r>
+            <a:endParaRPr lang="en-US" sz="2400" dirty="0"/>
+          </a:p>
+        </p:txBody>
+      </p:sp>
+      <p:sp>
+        <p:nvSpPr>
+          <p:cNvPr id="11" name="Text 8"/>
           <p:cNvSpPr txBox="1"/>
           <p:nvPr/>
         </p:nvSpPr>
         <p:spPr>
           <a:xfrm>
-            <a:off x="457200" y="4297680"/>
-            <a:ext cx="8229600" cy="365760"/>
+            <a:off x="457200" y="4023360"/>
+            <a:ext cx="8275320" cy="640080"/>
           </a:xfrm>
           <a:prstGeom prst="rect">
             <a:avLst/>
@@ -5920,14 +5741,14 @@
           <a:ln/>
         </p:spPr>
         <p:txBody>
-          <a:bodyPr wrap="square" lIns="0" tIns="0" rIns="0" bIns="0" rtlCol="0" anchor="ctr"/>
-          <a:lstStyle/>
-          <a:p>
-            <a:pPr indent="0" marL="0">
-              <a:buNone/>
-            </a:pPr>
-            <a:r>
-              <a:rPr lang="en-US" sz="1400" i="1" dirty="0">
+          <a:bodyPr wrap="square" lIns="0" tIns="0" rIns="0" bIns="0" rtlCol="0" anchor="t"/>
+          <a:lstStyle/>
+          <a:p>
+            <a:pPr indent="0" marL="0">
+              <a:buNone/>
+            </a:pPr>
+            <a:r>
+              <a:rPr lang="en-US" sz="1300" b="1" dirty="0">
                 <a:solidFill>
                   <a:srgbClr val="167F71"/>
                 </a:solidFill>
@@ -5935,9 +5756,23 @@
                 <a:ea typeface="Calibri" pitchFamily="34" charset="-122"/>
                 <a:cs typeface="Calibri" pitchFamily="34" charset="-120"/>
               </a:rPr>
-              <a:t>The moment we fix: the end of a busy day, register on the desk, DVDMS still open.</a:t>
-            </a:r>
-            <a:endParaRPr lang="en-US" sz="1400" dirty="0"/>
+              <a:t>Phase 3, live: </a:t>
+            </a:r>
+            <a:pPr indent="0" marL="0">
+              <a:buNone/>
+            </a:pPr>
+            <a:r>
+              <a:rPr lang="en-US" sz="1300" dirty="0">
+                <a:solidFill>
+                  <a:srgbClr val="16323A"/>
+                </a:solidFill>
+                <a:latin typeface="Calibri" pitchFamily="34" charset="0"/>
+                <a:ea typeface="Calibri" pitchFamily="34" charset="-122"/>
+                <a:cs typeface="Calibri" pitchFamily="34" charset="-120"/>
+              </a:rPr>
+              <a:t>batches that would expire unused are matched to the nearest facility running short; the district officer approves each move and downloads transfer orders.</a:t>
+            </a:r>
+            <a:endParaRPr lang="en-US" sz="1300" dirty="0"/>
           </a:p>
         </p:txBody>
       </p:sp>
@@ -8313,8 +8148,8 @@
           <p:nvPr/>
         </p:nvGraphicFramePr>
         <p:xfrm>
-          <a:off x="365760" y="1143000"/>
-          <a:ext cx="4937760" cy="3246120"/>
+          <a:off x="365760" y="1097280"/>
+          <a:ext cx="5029200" cy="3291840"/>
         </p:xfrm>
         <a:graphic xmlns:a="http://schemas.openxmlformats.org/drawingml/2006/main">
           <a:graphicData uri="http://schemas.openxmlformats.org/drawingml/2006/chart">
@@ -8330,8 +8165,8 @@
         </p:nvSpPr>
         <p:spPr>
           <a:xfrm>
-            <a:off x="5532120" y="1188720"/>
-            <a:ext cx="3154680" cy="3200400"/>
+            <a:off x="5577840" y="1143000"/>
+            <a:ext cx="3154680" cy="3291840"/>
           </a:xfrm>
           <a:prstGeom prst="roundRect">
             <a:avLst>
@@ -8364,8 +8199,8 @@
         </p:nvSpPr>
         <p:spPr>
           <a:xfrm>
-            <a:off x="5715000" y="1280160"/>
-            <a:ext cx="2834640" cy="3017520"/>
+            <a:off x="5742432" y="1234440"/>
+            <a:ext cx="2852928" cy="3154680"/>
           </a:xfrm>
           <a:prstGeom prst="rect">
             <a:avLst/>
@@ -8381,7 +8216,7 @@
               <a:buNone/>
             </a:pPr>
             <a:r>
-              <a:rPr lang="en-US" sz="1800" b="1" dirty="0">
+              <a:rPr lang="en-US" sz="1500" b="1" dirty="0">
                 <a:solidFill>
                   <a:srgbClr val="167F71"/>
                 </a:solidFill>
@@ -8389,16 +8224,16 @@
                 <a:ea typeface="Cambria" pitchFamily="34" charset="-122"/>
                 <a:cs typeface="Cambria" pitchFamily="34" charset="-120"/>
               </a:rPr>
-              <a:t>168 lines · 12 pages</a:t>
-            </a:r>
-            <a:endParaRPr lang="en-US" sz="1800" dirty="0"/>
-          </a:p>
-          <a:p>
-            <a:pPr indent="0" marL="0">
-              <a:buNone/>
-            </a:pPr>
-            <a:r>
-              <a:rPr lang="en-US" sz="1200" dirty="0">
+              <a:t>Drug names: 100% everywhere</a:t>
+            </a:r>
+            <a:endParaRPr lang="en-US" sz="1500" dirty="0"/>
+          </a:p>
+          <a:p>
+            <a:pPr indent="0" marL="0">
+              <a:buNone/>
+            </a:pPr>
+            <a:r>
+              <a:rPr lang="en-US" sz="1100" dirty="0">
                 <a:solidFill>
                   <a:srgbClr val="16323A"/>
                 </a:solidFill>
@@ -8406,9 +8241,9 @@
                 <a:ea typeface="Calibri" pitchFamily="34" charset="-122"/>
                 <a:cs typeface="Calibri" pitchFamily="34" charset="-120"/>
               </a:rPr>
-              <a:t>Drug names and every quantity: 100%.</a:t>
-            </a:r>
-            <a:endParaRPr lang="en-US" sz="1800" dirty="0"/>
+              <a:t>Quantities, which drive stock-out numbers: 100% on clean pages, 93% on messy ones.</a:t>
+            </a:r>
+            <a:endParaRPr lang="en-US" sz="1500" dirty="0"/>
           </a:p>
           <a:p>
             <a:pPr indent="0" marL="0">
@@ -8425,14 +8260,14 @@
               </a:rPr>
               <a:t> </a:t>
             </a:r>
-            <a:endParaRPr lang="en-US" sz="1800" dirty="0"/>
-          </a:p>
-          <a:p>
-            <a:pPr indent="0" marL="0">
-              <a:buNone/>
-            </a:pPr>
-            <a:r>
-              <a:rPr lang="en-US" sz="1250" b="1" dirty="0">
+            <a:endParaRPr lang="en-US" sz="1500" dirty="0"/>
+          </a:p>
+          <a:p>
+            <a:pPr indent="0" marL="0">
+              <a:buNone/>
+            </a:pPr>
+            <a:r>
+              <a:rPr lang="en-US" sz="1200" b="1" dirty="0">
                 <a:solidFill>
                   <a:srgbClr val="16323A"/>
                 </a:solidFill>
@@ -8440,16 +8275,16 @@
                 <a:ea typeface="Calibri" pitchFamily="34" charset="-122"/>
                 <a:cs typeface="Calibri" pitchFamily="34" charset="-120"/>
               </a:rPr>
-              <a:t>The 7 misses</a:t>
-            </a:r>
-            <a:endParaRPr lang="en-US" sz="1800" dirty="0"/>
-          </a:p>
-          <a:p>
-            <a:pPr indent="0" marL="0">
-              <a:buNone/>
-            </a:pPr>
-            <a:r>
-              <a:rPr lang="en-US" sz="1150" dirty="0">
+              <a:t>The weak spot</a:t>
+            </a:r>
+            <a:endParaRPr lang="en-US" sz="1500" dirty="0"/>
+          </a:p>
+          <a:p>
+            <a:pPr indent="0" marL="0">
+              <a:buNone/>
+            </a:pPr>
+            <a:r>
+              <a:rPr lang="en-US" sz="1100" dirty="0">
                 <a:solidFill>
                   <a:srgbClr val="5B7780"/>
                 </a:solidFill>
@@ -8457,9 +8292,9 @@
                 <a:ea typeface="Calibri" pitchFamily="34" charset="-122"/>
                 <a:cs typeface="Calibri" pitchFamily="34" charset="-120"/>
               </a:rPr>
-              <a:t>All on hard pages, single digits in batch or expiry. Gemini scored every one at 0.95, so its confidence did not catch them.</a:t>
-            </a:r>
-            <a:endParaRPr lang="en-US" sz="1800" dirty="0"/>
+              <a:t>Small cursive batch codes and expiry dates on messy pages (G/U, E/C, 3/8). Gemini's own confidence caught only 4 of 104 wrong values.</a:t>
+            </a:r>
+            <a:endParaRPr lang="en-US" sz="1500" dirty="0"/>
           </a:p>
           <a:p>
             <a:pPr indent="0" marL="0">
@@ -8476,14 +8311,14 @@
               </a:rPr>
               <a:t> </a:t>
             </a:r>
-            <a:endParaRPr lang="en-US" sz="1800" dirty="0"/>
-          </a:p>
-          <a:p>
-            <a:pPr indent="0" marL="0">
-              <a:buNone/>
-            </a:pPr>
-            <a:r>
-              <a:rPr lang="en-US" sz="1250" b="1" dirty="0">
+            <a:endParaRPr lang="en-US" sz="1500" dirty="0"/>
+          </a:p>
+          <a:p>
+            <a:pPr indent="0" marL="0">
+              <a:buNone/>
+            </a:pPr>
+            <a:r>
+              <a:rPr lang="en-US" sz="1200" b="1" dirty="0">
                 <a:solidFill>
                   <a:srgbClr val="16323A"/>
                 </a:solidFill>
@@ -8493,14 +8328,14 @@
               </a:rPr>
               <a:t>Our fix</a:t>
             </a:r>
-            <a:endParaRPr lang="en-US" sz="1800" dirty="0"/>
-          </a:p>
-          <a:p>
-            <a:pPr indent="0" marL="0">
-              <a:buNone/>
-            </a:pPr>
-            <a:r>
-              <a:rPr lang="en-US" sz="1150" dirty="0">
+            <a:endParaRPr lang="en-US" sz="1500" dirty="0"/>
+          </a:p>
+          <a:p>
+            <a:pPr indent="0" marL="0">
+              <a:buNone/>
+            </a:pPr>
+            <a:r>
+              <a:rPr lang="en-US" sz="1100" dirty="0">
                 <a:solidFill>
                   <a:srgbClr val="5B7780"/>
                 </a:solidFill>
@@ -8508,9 +8343,9 @@
                 <a:ea typeface="Calibri" pitchFamily="34" charset="-122"/>
                 <a:cs typeface="Calibri" pitchFamily="34" charset="-120"/>
               </a:rPr>
-              <a:t>Cross-check against batches DVDMS already lists: 7 of 7 flagged, 0 false alarms on 161 correct lines.</a:t>
-            </a:r>
-            <a:endParaRPr lang="en-US" sz="1800" dirty="0"/>
+              <a:t>DVDMS batch cross-check + balance check flagged 63 of 74 lines with errors for the pharmacist, 0 false alarms.</a:t>
+            </a:r>
+            <a:endParaRPr lang="en-US" sz="1500" dirty="0"/>
           </a:p>
         </p:txBody>
       </p:sp>
@@ -8522,7 +8357,7 @@
         </p:nvSpPr>
         <p:spPr>
           <a:xfrm>
-            <a:off x="457200" y="4498848"/>
+            <a:off x="457200" y="4526280"/>
             <a:ext cx="8229600" cy="457200"/>
           </a:xfrm>
           <a:prstGeom prst="rect">
@@ -8539,7 +8374,7 @@
               <a:buNone/>
             </a:pPr>
             <a:r>
-              <a:rPr lang="en-US" sz="1000" i="1" dirty="0">
+              <a:rPr lang="en-US" sz="950" i="1" dirty="0">
                 <a:solidFill>
                   <a:srgbClr val="5B7780"/>
                 </a:solidFill>
@@ -8547,9 +8382,9 @@
                 <a:ea typeface="Calibri" pitchFamily="34" charset="-122"/>
                 <a:cs typeface="Calibri" pitchFamily="34" charset="-120"/>
               </a:rPr>
-              <a:t>Synthetic handwritten pages; real registers will be messier. The demo DVDMS is a mock seeded with the correct batches, so the cross-check shows the mechanism, not a field catch rate.</a:t>
-            </a:r>
-            <a:endParaRPr lang="en-US" sz="1000" dirty="0"/>
+              <a:t>Messy pages: ruled notebooks, no column lines, cursive, corrections, Hindi numerals, stains, folds, blur. All pages synthetic; the demo DVDMS is a mock seeded with correct batches, so the cross-check shows the mechanism, not a field catch rate.</a:t>
+            </a:r>
+            <a:endParaRPr lang="en-US" sz="950" dirty="0"/>
           </a:p>
         </p:txBody>
       </p:sp>
@@ -8618,37 +8453,34 @@
                 <a:ea typeface="Cambria" pitchFamily="34" charset="-122"/>
                 <a:cs typeface="Cambria" pitchFamily="34" charset="-120"/>
               </a:rPr>
-              <a:t>When it is wrong, a person catches it</a:t>
+              <a:t>Ask it anything. Use it on any phone.</a:t>
             </a:r>
             <a:endParaRPr lang="en-US" sz="3000" dirty="0"/>
           </a:p>
         </p:txBody>
       </p:sp>
-      <p:sp>
-        <p:nvSpPr>
-          <p:cNvPr id="3" name="Shape 1"/>
-          <p:cNvSpPr/>
-          <p:nvPr/>
-        </p:nvSpPr>
-        <p:spPr>
-          <a:xfrm>
-            <a:off x="457200" y="1280160"/>
-            <a:ext cx="2606040" cy="1417320"/>
-          </a:xfrm>
-          <a:prstGeom prst="roundRect">
-            <a:avLst>
-              <a:gd name="adj" fmla="val 7742"/>
-            </a:avLst>
-          </a:prstGeom>
-          <a:solidFill>
-            <a:srgbClr val="FFFFFF"/>
-          </a:solidFill>
-          <a:ln w="9525">
-            <a:solidFill>
-              <a:srgbClr val="DCEBE7"/>
-            </a:solidFill>
-            <a:prstDash val="solid"/>
-          </a:ln>
+      <p:pic>
+        <p:nvPicPr>
+          <p:cNvPr id="3" name="Image 0" descr="D:\RegisterLens\docs\deck\img_crop\chat.png">    </p:cNvPr>
+          <p:cNvPicPr>
+            <a:picLocks noChangeAspect="1"/>
+          </p:cNvPicPr>
+          <p:nvPr/>
+        </p:nvPicPr>
+        <p:blipFill>
+          <a:blip r:embed="rId1"/>
+          <a:stretch>
+            <a:fillRect/>
+          </a:stretch>
+        </p:blipFill>
+        <p:spPr>
+          <a:xfrm>
+            <a:off x="457200" y="1143000"/>
+            <a:ext cx="2468880" cy="3566160"/>
+          </a:xfrm>
+          <a:prstGeom prst="rect">
+            <a:avLst/>
+          </a:prstGeom>
           <a:effectLst>
             <a:outerShdw sx="100000" sy="100000" kx="0" ky="0" algn="bl" rotWithShape="0" blurRad="127000" dist="38100" dir="5400000">
               <a:srgbClr val="14665C">
@@ -8657,42 +8489,17 @@
             </a:outerShdw>
           </a:effectLst>
         </p:spPr>
-      </p:sp>
-      <p:sp>
-        <p:nvSpPr>
-          <p:cNvPr id="4" name="Shape 2"/>
-          <p:cNvSpPr/>
-          <p:nvPr/>
-        </p:nvSpPr>
-        <p:spPr>
-          <a:xfrm>
-            <a:off x="640080" y="1463040"/>
-            <a:ext cx="310896" cy="310896"/>
-          </a:xfrm>
-          <a:prstGeom prst="ellipse">
-            <a:avLst/>
-          </a:prstGeom>
-          <a:solidFill>
-            <a:srgbClr val="F0A23B"/>
-          </a:solidFill>
-          <a:ln w="12700">
-            <a:solidFill>
-              <a:srgbClr val="F0A23B"/>
-            </a:solidFill>
-            <a:prstDash val="solid"/>
-          </a:ln>
-        </p:spPr>
-      </p:sp>
-      <p:sp>
-        <p:nvSpPr>
-          <p:cNvPr id="5" name="Text 3"/>
+      </p:pic>
+      <p:sp>
+        <p:nvSpPr>
+          <p:cNvPr id="4" name="Text 1"/>
           <p:cNvSpPr txBox="1"/>
           <p:nvPr/>
         </p:nvSpPr>
         <p:spPr>
           <a:xfrm>
-            <a:off x="1051560" y="1417320"/>
-            <a:ext cx="1874520" cy="411480"/>
+            <a:off x="3108960" y="1143000"/>
+            <a:ext cx="2377440" cy="2011680"/>
           </a:xfrm>
           <a:prstGeom prst="rect">
             <a:avLst/>
@@ -8701,91 +8508,122 @@
           <a:ln/>
         </p:spPr>
         <p:txBody>
-          <a:bodyPr wrap="square" lIns="0" tIns="0" rIns="0" bIns="0" rtlCol="0" anchor="ctr"/>
-          <a:lstStyle/>
-          <a:p>
-            <a:pPr indent="0" marL="0">
-              <a:buNone/>
-            </a:pPr>
-            <a:r>
-              <a:rPr lang="en-US" sz="1350" b="1" dirty="0">
+          <a:bodyPr wrap="square" lIns="0" tIns="0" rIns="0" bIns="0" rtlCol="0" anchor="t"/>
+          <a:lstStyle/>
+          <a:p>
+            <a:pPr indent="0" marL="0">
+              <a:buNone/>
+            </a:pPr>
+            <a:r>
+              <a:rPr lang="en-US" sz="1400" b="1" dirty="0">
                 <a:solidFill>
                   <a:srgbClr val="16323A"/>
-                </a:solidFill>
-                <a:latin typeface="Cambria" pitchFamily="34" charset="0"/>
-                <a:ea typeface="Cambria" pitchFamily="34" charset="-122"/>
-                <a:cs typeface="Cambria" pitchFamily="34" charset="-120"/>
-              </a:rPr>
-              <a:t>Unsure cell</a:t>
-            </a:r>
-            <a:endParaRPr lang="en-US" sz="1350" dirty="0"/>
-          </a:p>
-        </p:txBody>
-      </p:sp>
-      <p:sp>
-        <p:nvSpPr>
-          <p:cNvPr id="6" name="Text 4"/>
-          <p:cNvSpPr txBox="1"/>
-          <p:nvPr/>
-        </p:nvSpPr>
-        <p:spPr>
-          <a:xfrm>
-            <a:off x="640080" y="1920240"/>
-            <a:ext cx="2286000" cy="713232"/>
-          </a:xfrm>
-          <a:prstGeom prst="rect">
-            <a:avLst/>
-          </a:prstGeom>
-          <a:noFill/>
-          <a:ln/>
-        </p:spPr>
-        <p:txBody>
-          <a:bodyPr wrap="square" lIns="0" tIns="0" rIns="0" bIns="0" rtlCol="0" anchor="t"/>
-          <a:lstStyle/>
-          <a:p>
-            <a:pPr indent="0" marL="0">
-              <a:buNone/>
-            </a:pPr>
-            <a:r>
-              <a:rPr lang="en-US" sz="1150" dirty="0">
-                <a:solidFill>
-                  <a:srgbClr val="5B7780"/>
                 </a:solidFill>
                 <a:latin typeface="Calibri" pitchFamily="34" charset="0"/>
                 <a:ea typeface="Calibri" pitchFamily="34" charset="-122"/>
                 <a:cs typeface="Calibri" pitchFamily="34" charset="-120"/>
               </a:rPr>
-              <a:t>Highlighted yellow; the pharmacist confirms or edits it.</a:t>
-            </a:r>
-            <a:endParaRPr lang="en-US" sz="1150" dirty="0"/>
-          </a:p>
-        </p:txBody>
-      </p:sp>
-      <p:sp>
-        <p:nvSpPr>
-          <p:cNvPr id="7" name="Shape 5"/>
-          <p:cNvSpPr/>
-          <p:nvPr/>
-        </p:nvSpPr>
-        <p:spPr>
-          <a:xfrm>
-            <a:off x="3246120" y="1280160"/>
-            <a:ext cx="2606040" cy="1417320"/>
-          </a:xfrm>
-          <a:prstGeom prst="roundRect">
-            <a:avLst>
-              <a:gd name="adj" fmla="val 7742"/>
-            </a:avLst>
-          </a:prstGeom>
-          <a:solidFill>
-            <a:srgbClr val="FFFFFF"/>
-          </a:solidFill>
-          <a:ln w="9525">
-            <a:solidFill>
-              <a:srgbClr val="DCEBE7"/>
-            </a:solidFill>
-            <a:prstDash val="solid"/>
-          </a:ln>
+              <a:t>Gemini assistant with function calling</a:t>
+            </a:r>
+            <a:endParaRPr lang="en-US" sz="1400" dirty="0"/>
+          </a:p>
+          <a:p>
+            <a:pPr indent="0" marL="0">
+              <a:buNone/>
+            </a:pPr>
+            <a:r>
+              <a:rPr lang="en-US" sz="1150" dirty="0">
+                <a:solidFill>
+                  <a:srgbClr val="5B7780"/>
+                </a:solidFill>
+                <a:latin typeface="Calibri" pitchFamily="34" charset="0"/>
+                <a:ea typeface="Calibri" pitchFamily="34" charset="-122"/>
+                <a:cs typeface="Calibri" pitchFamily="34" charset="-120"/>
+              </a:rPr>
+              <a:t>Looks up districts, facilities, nearby stock and transfer plans before answering, so it never invents a number. Replies in Hindi, Hinglish or English. Voice input.</a:t>
+            </a:r>
+            <a:endParaRPr lang="en-US" sz="1400" dirty="0"/>
+          </a:p>
+        </p:txBody>
+      </p:sp>
+      <p:sp>
+        <p:nvSpPr>
+          <p:cNvPr id="5" name="Text 2"/>
+          <p:cNvSpPr txBox="1"/>
+          <p:nvPr/>
+        </p:nvSpPr>
+        <p:spPr>
+          <a:xfrm>
+            <a:off x="3108960" y="3063240"/>
+            <a:ext cx="2377440" cy="1645920"/>
+          </a:xfrm>
+          <a:prstGeom prst="rect">
+            <a:avLst/>
+          </a:prstGeom>
+          <a:noFill/>
+          <a:ln/>
+        </p:spPr>
+        <p:txBody>
+          <a:bodyPr wrap="square" lIns="0" tIns="0" rIns="0" bIns="0" rtlCol="0" anchor="t"/>
+          <a:lstStyle/>
+          <a:p>
+            <a:pPr indent="0" marL="0">
+              <a:buNone/>
+            </a:pPr>
+            <a:r>
+              <a:rPr lang="en-US" sz="1400" b="1" dirty="0">
+                <a:solidFill>
+                  <a:srgbClr val="16323A"/>
+                </a:solidFill>
+                <a:latin typeface="Calibri" pitchFamily="34" charset="0"/>
+                <a:ea typeface="Calibri" pitchFamily="34" charset="-122"/>
+                <a:cs typeface="Calibri" pitchFamily="34" charset="-120"/>
+              </a:rPr>
+              <a:t>Installable phone app (PWA)</a:t>
+            </a:r>
+            <a:endParaRPr lang="en-US" sz="1400" dirty="0"/>
+          </a:p>
+          <a:p>
+            <a:pPr indent="0" marL="0">
+              <a:buNone/>
+            </a:pPr>
+            <a:r>
+              <a:rPr lang="en-US" sz="1150" dirty="0">
+                <a:solidFill>
+                  <a:srgbClr val="5B7780"/>
+                </a:solidFill>
+                <a:latin typeface="Calibri" pitchFamily="34" charset="0"/>
+                <a:ea typeface="Calibri" pitchFamily="34" charset="-122"/>
+                <a:cs typeface="Calibri" pitchFamily="34" charset="-120"/>
+              </a:rPr>
+              <a:t>Open the link in Chrome, tap Install. Own icon, full screen, Scan opens the camera. No app store needed.</a:t>
+            </a:r>
+            <a:endParaRPr lang="en-US" sz="1400" dirty="0"/>
+          </a:p>
+        </p:txBody>
+      </p:sp>
+      <p:pic>
+        <p:nvPicPr>
+          <p:cNvPr id="6" name="Image 1" descr="D:\RegisterLens\docs\deck\img_crop\11_mobile_home.png">    </p:cNvPr>
+          <p:cNvPicPr>
+            <a:picLocks noChangeAspect="1"/>
+          </p:cNvPicPr>
+          <p:nvPr/>
+        </p:nvPicPr>
+        <p:blipFill>
+          <a:blip r:embed="rId2"/>
+          <a:stretch>
+            <a:fillRect/>
+          </a:stretch>
+        </p:blipFill>
+        <p:spPr>
+          <a:xfrm>
+            <a:off x="5715000" y="1143000"/>
+            <a:ext cx="1417320" cy="2523744"/>
+          </a:xfrm>
+          <a:prstGeom prst="rect">
+            <a:avLst/>
+          </a:prstGeom>
           <a:effectLst>
             <a:outerShdw sx="100000" sy="100000" kx="0" ky="0" algn="bl" rotWithShape="0" blurRad="127000" dist="38100" dir="5400000">
               <a:srgbClr val="14665C">
@@ -8794,135 +8632,29 @@
             </a:outerShdw>
           </a:effectLst>
         </p:spPr>
-      </p:sp>
-      <p:sp>
-        <p:nvSpPr>
-          <p:cNvPr id="8" name="Shape 6"/>
-          <p:cNvSpPr/>
-          <p:nvPr/>
-        </p:nvSpPr>
-        <p:spPr>
-          <a:xfrm>
-            <a:off x="3429000" y="1463040"/>
-            <a:ext cx="310896" cy="310896"/>
-          </a:xfrm>
-          <a:prstGeom prst="ellipse">
-            <a:avLst/>
-          </a:prstGeom>
-          <a:solidFill>
-            <a:srgbClr val="E5484D"/>
-          </a:solidFill>
-          <a:ln w="12700">
-            <a:solidFill>
-              <a:srgbClr val="E5484D"/>
-            </a:solidFill>
-            <a:prstDash val="solid"/>
-          </a:ln>
-        </p:spPr>
-      </p:sp>
-      <p:sp>
-        <p:nvSpPr>
-          <p:cNvPr id="9" name="Text 7"/>
-          <p:cNvSpPr txBox="1"/>
-          <p:nvPr/>
-        </p:nvSpPr>
-        <p:spPr>
-          <a:xfrm>
-            <a:off x="3840480" y="1417320"/>
-            <a:ext cx="1874520" cy="411480"/>
-          </a:xfrm>
-          <a:prstGeom prst="rect">
-            <a:avLst/>
-          </a:prstGeom>
-          <a:noFill/>
-          <a:ln/>
-        </p:spPr>
-        <p:txBody>
-          <a:bodyPr wrap="square" lIns="0" tIns="0" rIns="0" bIns="0" rtlCol="0" anchor="ctr"/>
-          <a:lstStyle/>
-          <a:p>
-            <a:pPr indent="0" marL="0">
-              <a:buNone/>
-            </a:pPr>
-            <a:r>
-              <a:rPr lang="en-US" sz="1350" b="1" dirty="0">
-                <a:solidFill>
-                  <a:srgbClr val="16323A"/>
-                </a:solidFill>
-                <a:latin typeface="Cambria" pitchFamily="34" charset="0"/>
-                <a:ea typeface="Cambria" pitchFamily="34" charset="-122"/>
-                <a:cs typeface="Cambria" pitchFamily="34" charset="-120"/>
-              </a:rPr>
-              <a:t>Numbers do not add up</a:t>
-            </a:r>
-            <a:endParaRPr lang="en-US" sz="1350" dirty="0"/>
-          </a:p>
-        </p:txBody>
-      </p:sp>
-      <p:sp>
-        <p:nvSpPr>
-          <p:cNvPr id="10" name="Text 8"/>
-          <p:cNvSpPr txBox="1"/>
-          <p:nvPr/>
-        </p:nvSpPr>
-        <p:spPr>
-          <a:xfrm>
-            <a:off x="3429000" y="1920240"/>
-            <a:ext cx="2286000" cy="713232"/>
-          </a:xfrm>
-          <a:prstGeom prst="rect">
-            <a:avLst/>
-          </a:prstGeom>
-          <a:noFill/>
-          <a:ln/>
-        </p:spPr>
-        <p:txBody>
-          <a:bodyPr wrap="square" lIns="0" tIns="0" rIns="0" bIns="0" rtlCol="0" anchor="t"/>
-          <a:lstStyle/>
-          <a:p>
-            <a:pPr indent="0" marL="0">
-              <a:buNone/>
-            </a:pPr>
-            <a:r>
-              <a:rPr lang="en-US" sz="1150" dirty="0">
-                <a:solidFill>
-                  <a:srgbClr val="5B7780"/>
-                </a:solidFill>
-                <a:latin typeface="Calibri" pitchFamily="34" charset="0"/>
-                <a:ea typeface="Calibri" pitchFamily="34" charset="-122"/>
-                <a:cs typeface="Calibri" pitchFamily="34" charset="-120"/>
-              </a:rPr>
-              <a:t>Opening + received − issued ≠ closing turns red.</a:t>
-            </a:r>
-            <a:endParaRPr lang="en-US" sz="1150" dirty="0"/>
-          </a:p>
-        </p:txBody>
-      </p:sp>
-      <p:sp>
-        <p:nvSpPr>
-          <p:cNvPr id="11" name="Shape 9"/>
-          <p:cNvSpPr/>
-          <p:nvPr/>
-        </p:nvSpPr>
-        <p:spPr>
-          <a:xfrm>
-            <a:off x="6035040" y="1280160"/>
-            <a:ext cx="2606040" cy="1417320"/>
-          </a:xfrm>
-          <a:prstGeom prst="roundRect">
-            <a:avLst>
-              <a:gd name="adj" fmla="val 7742"/>
-            </a:avLst>
-          </a:prstGeom>
-          <a:solidFill>
-            <a:srgbClr val="FFFFFF"/>
-          </a:solidFill>
-          <a:ln w="9525">
-            <a:solidFill>
-              <a:srgbClr val="DCEBE7"/>
-            </a:solidFill>
-            <a:prstDash val="solid"/>
-          </a:ln>
+      </p:pic>
+      <p:pic>
+        <p:nvPicPr>
+          <p:cNvPr id="7" name="Image 2" descr="D:\RegisterLens\docs\deck\img_crop\13_mobile_map.png">    </p:cNvPr>
+          <p:cNvPicPr>
+            <a:picLocks noChangeAspect="1"/>
+          </p:cNvPicPr>
+          <p:nvPr/>
+        </p:nvPicPr>
+        <p:blipFill>
+          <a:blip r:embed="rId3"/>
+          <a:stretch>
+            <a:fillRect/>
+          </a:stretch>
+        </p:blipFill>
+        <p:spPr>
+          <a:xfrm>
+            <a:off x="7269480" y="1143000"/>
+            <a:ext cx="1417320" cy="2523744"/>
+          </a:xfrm>
+          <a:prstGeom prst="rect">
+            <a:avLst/>
+          </a:prstGeom>
           <a:effectLst>
             <a:outerShdw sx="100000" sy="100000" kx="0" ky="0" algn="bl" rotWithShape="0" blurRad="127000" dist="38100" dir="5400000">
               <a:srgbClr val="14665C">
@@ -8931,42 +8663,17 @@
             </a:outerShdw>
           </a:effectLst>
         </p:spPr>
-      </p:sp>
-      <p:sp>
-        <p:nvSpPr>
-          <p:cNvPr id="12" name="Shape 10"/>
-          <p:cNvSpPr/>
-          <p:nvPr/>
-        </p:nvSpPr>
-        <p:spPr>
-          <a:xfrm>
-            <a:off x="6217920" y="1463040"/>
-            <a:ext cx="310896" cy="310896"/>
-          </a:xfrm>
-          <a:prstGeom prst="ellipse">
-            <a:avLst/>
-          </a:prstGeom>
-          <a:solidFill>
-            <a:srgbClr val="3B9CE2"/>
-          </a:solidFill>
-          <a:ln w="12700">
-            <a:solidFill>
-              <a:srgbClr val="3B9CE2"/>
-            </a:solidFill>
-            <a:prstDash val="solid"/>
-          </a:ln>
-        </p:spPr>
-      </p:sp>
-      <p:sp>
-        <p:nvSpPr>
-          <p:cNvPr id="13" name="Text 11"/>
+      </p:pic>
+      <p:sp>
+        <p:nvSpPr>
+          <p:cNvPr id="8" name="Text 3"/>
           <p:cNvSpPr txBox="1"/>
           <p:nvPr/>
         </p:nvSpPr>
         <p:spPr>
           <a:xfrm>
-            <a:off x="6629400" y="1417320"/>
-            <a:ext cx="1874520" cy="411480"/>
+            <a:off x="5715000" y="3749040"/>
+            <a:ext cx="3017520" cy="274320"/>
           </a:xfrm>
           <a:prstGeom prst="rect">
             <a:avLst/>
@@ -8982,46 +8689,7 @@
               <a:buNone/>
             </a:pPr>
             <a:r>
-              <a:rPr lang="en-US" sz="1350" b="1" dirty="0">
-                <a:solidFill>
-                  <a:srgbClr val="16323A"/>
-                </a:solidFill>
-                <a:latin typeface="Cambria" pitchFamily="34" charset="0"/>
-                <a:ea typeface="Cambria" pitchFamily="34" charset="-122"/>
-                <a:cs typeface="Cambria" pitchFamily="34" charset="-120"/>
-              </a:rPr>
-              <a:t>Batch looks off</a:t>
-            </a:r>
-            <a:endParaRPr lang="en-US" sz="1350" dirty="0"/>
-          </a:p>
-        </p:txBody>
-      </p:sp>
-      <p:sp>
-        <p:nvSpPr>
-          <p:cNvPr id="14" name="Text 12"/>
-          <p:cNvSpPr txBox="1"/>
-          <p:nvPr/>
-        </p:nvSpPr>
-        <p:spPr>
-          <a:xfrm>
-            <a:off x="6217920" y="1920240"/>
-            <a:ext cx="2286000" cy="713232"/>
-          </a:xfrm>
-          <a:prstGeom prst="rect">
-            <a:avLst/>
-          </a:prstGeom>
-          <a:noFill/>
-          <a:ln/>
-        </p:spPr>
-        <p:txBody>
-          <a:bodyPr wrap="square" lIns="0" tIns="0" rIns="0" bIns="0" rtlCol="0" anchor="t"/>
-          <a:lstStyle/>
-          <a:p>
-            <a:pPr indent="0" marL="0">
-              <a:buNone/>
-            </a:pPr>
-            <a:r>
-              <a:rPr lang="en-US" sz="1150" dirty="0">
+              <a:rPr lang="en-US" sz="1000" dirty="0">
                 <a:solidFill>
                   <a:srgbClr val="5B7780"/>
                 </a:solidFill>
@@ -9029,81 +8697,22 @@
                 <a:ea typeface="Calibri" pitchFamily="34" charset="-122"/>
                 <a:cs typeface="Calibri" pitchFamily="34" charset="-120"/>
               </a:rPr>
-              <a:t>Compared with DVDMS batches; “looks like BC7284” prompts a check.</a:t>
-            </a:r>
-            <a:endParaRPr lang="en-US" sz="1150" dirty="0"/>
-          </a:p>
-        </p:txBody>
-      </p:sp>
-      <p:sp>
-        <p:nvSpPr>
-          <p:cNvPr id="15" name="Shape 13"/>
-          <p:cNvSpPr/>
-          <p:nvPr/>
-        </p:nvSpPr>
-        <p:spPr>
-          <a:xfrm>
-            <a:off x="457200" y="2880360"/>
-            <a:ext cx="2606040" cy="1417320"/>
-          </a:xfrm>
-          <a:prstGeom prst="roundRect">
-            <a:avLst>
-              <a:gd name="adj" fmla="val 7742"/>
-            </a:avLst>
-          </a:prstGeom>
-          <a:solidFill>
-            <a:srgbClr val="FFFFFF"/>
-          </a:solidFill>
-          <a:ln w="9525">
-            <a:solidFill>
-              <a:srgbClr val="DCEBE7"/>
-            </a:solidFill>
-            <a:prstDash val="solid"/>
-          </a:ln>
-          <a:effectLst>
-            <a:outerShdw sx="100000" sy="100000" kx="0" ky="0" algn="bl" rotWithShape="0" blurRad="127000" dist="38100" dir="5400000">
-              <a:srgbClr val="14665C">
-                <a:alpha val="18000"/>
-              </a:srgbClr>
-            </a:outerShdw>
-          </a:effectLst>
-        </p:spPr>
-      </p:sp>
-      <p:sp>
-        <p:nvSpPr>
-          <p:cNvPr id="16" name="Shape 14"/>
-          <p:cNvSpPr/>
-          <p:nvPr/>
-        </p:nvSpPr>
-        <p:spPr>
-          <a:xfrm>
-            <a:off x="640080" y="3063240"/>
-            <a:ext cx="310896" cy="310896"/>
-          </a:xfrm>
-          <a:prstGeom prst="ellipse">
-            <a:avLst/>
-          </a:prstGeom>
-          <a:solidFill>
-            <a:srgbClr val="167F71"/>
-          </a:solidFill>
-          <a:ln w="12700">
-            <a:solidFill>
-              <a:srgbClr val="167F71"/>
-            </a:solidFill>
-            <a:prstDash val="solid"/>
-          </a:ln>
-        </p:spPr>
-      </p:sp>
-      <p:sp>
-        <p:nvSpPr>
-          <p:cNvPr id="17" name="Text 15"/>
+              <a:t>Phone views: home and district map</a:t>
+            </a:r>
+            <a:endParaRPr lang="en-US" sz="1000" dirty="0"/>
+          </a:p>
+        </p:txBody>
+      </p:sp>
+      <p:sp>
+        <p:nvSpPr>
+          <p:cNvPr id="9" name="Text 4"/>
           <p:cNvSpPr txBox="1"/>
           <p:nvPr/>
         </p:nvSpPr>
         <p:spPr>
           <a:xfrm>
-            <a:off x="1051560" y="3017520"/>
-            <a:ext cx="1874520" cy="411480"/>
+            <a:off x="5715000" y="4069080"/>
+            <a:ext cx="3017520" cy="685800"/>
           </a:xfrm>
           <a:prstGeom prst="rect">
             <a:avLst/>
@@ -9112,45 +8721,6 @@
           <a:ln/>
         </p:spPr>
         <p:txBody>
-          <a:bodyPr wrap="square" lIns="0" tIns="0" rIns="0" bIns="0" rtlCol="0" anchor="ctr"/>
-          <a:lstStyle/>
-          <a:p>
-            <a:pPr indent="0" marL="0">
-              <a:buNone/>
-            </a:pPr>
-            <a:r>
-              <a:rPr lang="en-US" sz="1350" b="1" dirty="0">
-                <a:solidFill>
-                  <a:srgbClr val="16323A"/>
-                </a:solidFill>
-                <a:latin typeface="Cambria" pitchFamily="34" charset="0"/>
-                <a:ea typeface="Cambria" pitchFamily="34" charset="-122"/>
-                <a:cs typeface="Cambria" pitchFamily="34" charset="-120"/>
-              </a:rPr>
-              <a:t>AI unavailable</a:t>
-            </a:r>
-            <a:endParaRPr lang="en-US" sz="1350" dirty="0"/>
-          </a:p>
-        </p:txBody>
-      </p:sp>
-      <p:sp>
-        <p:nvSpPr>
-          <p:cNvPr id="18" name="Text 16"/>
-          <p:cNvSpPr txBox="1"/>
-          <p:nvPr/>
-        </p:nvSpPr>
-        <p:spPr>
-          <a:xfrm>
-            <a:off x="640080" y="3520440"/>
-            <a:ext cx="2286000" cy="713232"/>
-          </a:xfrm>
-          <a:prstGeom prst="rect">
-            <a:avLst/>
-          </a:prstGeom>
-          <a:noFill/>
-          <a:ln/>
-        </p:spPr>
-        <p:txBody>
           <a:bodyPr wrap="square" lIns="0" tIns="0" rIns="0" bIns="0" rtlCol="0" anchor="t"/>
           <a:lstStyle/>
           <a:p>
@@ -9158,291 +8728,17 @@
               <a:buNone/>
             </a:pPr>
             <a:r>
-              <a:rPr lang="en-US" sz="1150" dirty="0">
-                <a:solidFill>
-                  <a:srgbClr val="5B7780"/>
+              <a:rPr lang="en-US" sz="1050" b="1" dirty="0">
+                <a:solidFill>
+                  <a:srgbClr val="167F71"/>
                 </a:solidFill>
                 <a:latin typeface="Calibri" pitchFamily="34" charset="0"/>
                 <a:ea typeface="Calibri" pitchFamily="34" charset="-122"/>
                 <a:cs typeface="Calibri" pitchFamily="34" charset="-120"/>
               </a:rPr>
-              <a:t>Clear message, nothing lost; sample pages work without the API.</a:t>
-            </a:r>
-            <a:endParaRPr lang="en-US" sz="1150" dirty="0"/>
-          </a:p>
-        </p:txBody>
-      </p:sp>
-      <p:sp>
-        <p:nvSpPr>
-          <p:cNvPr id="19" name="Shape 17"/>
-          <p:cNvSpPr/>
-          <p:nvPr/>
-        </p:nvSpPr>
-        <p:spPr>
-          <a:xfrm>
-            <a:off x="3246120" y="2880360"/>
-            <a:ext cx="2606040" cy="1417320"/>
-          </a:xfrm>
-          <a:prstGeom prst="roundRect">
-            <a:avLst>
-              <a:gd name="adj" fmla="val 7742"/>
-            </a:avLst>
-          </a:prstGeom>
-          <a:solidFill>
-            <a:srgbClr val="FFFFFF"/>
-          </a:solidFill>
-          <a:ln w="9525">
-            <a:solidFill>
-              <a:srgbClr val="DCEBE7"/>
-            </a:solidFill>
-            <a:prstDash val="solid"/>
-          </a:ln>
-          <a:effectLst>
-            <a:outerShdw sx="100000" sy="100000" kx="0" ky="0" algn="bl" rotWithShape="0" blurRad="127000" dist="38100" dir="5400000">
-              <a:srgbClr val="14665C">
-                <a:alpha val="18000"/>
-              </a:srgbClr>
-            </a:outerShdw>
-          </a:effectLst>
-        </p:spPr>
-      </p:sp>
-      <p:sp>
-        <p:nvSpPr>
-          <p:cNvPr id="20" name="Shape 18"/>
-          <p:cNvSpPr/>
-          <p:nvPr/>
-        </p:nvSpPr>
-        <p:spPr>
-          <a:xfrm>
-            <a:off x="3429000" y="3063240"/>
-            <a:ext cx="310896" cy="310896"/>
-          </a:xfrm>
-          <a:prstGeom prst="ellipse">
-            <a:avLst/>
-          </a:prstGeom>
-          <a:solidFill>
-            <a:srgbClr val="167F71"/>
-          </a:solidFill>
-          <a:ln w="12700">
-            <a:solidFill>
-              <a:srgbClr val="167F71"/>
-            </a:solidFill>
-            <a:prstDash val="solid"/>
-          </a:ln>
-        </p:spPr>
-      </p:sp>
-      <p:sp>
-        <p:nvSpPr>
-          <p:cNvPr id="21" name="Text 19"/>
-          <p:cNvSpPr txBox="1"/>
-          <p:nvPr/>
-        </p:nvSpPr>
-        <p:spPr>
-          <a:xfrm>
-            <a:off x="3840480" y="3017520"/>
-            <a:ext cx="1874520" cy="411480"/>
-          </a:xfrm>
-          <a:prstGeom prst="rect">
-            <a:avLst/>
-          </a:prstGeom>
-          <a:noFill/>
-          <a:ln/>
-        </p:spPr>
-        <p:txBody>
-          <a:bodyPr wrap="square" lIns="0" tIns="0" rIns="0" bIns="0" rtlCol="0" anchor="ctr"/>
-          <a:lstStyle/>
-          <a:p>
-            <a:pPr indent="0" marL="0">
-              <a:buNone/>
-            </a:pPr>
-            <a:r>
-              <a:rPr lang="en-US" sz="1350" b="1" dirty="0">
-                <a:solidFill>
-                  <a:srgbClr val="16323A"/>
-                </a:solidFill>
-                <a:latin typeface="Cambria" pitchFamily="34" charset="0"/>
-                <a:ea typeface="Cambria" pitchFamily="34" charset="-122"/>
-                <a:cs typeface="Cambria" pitchFamily="34" charset="-120"/>
-              </a:rPr>
-              <a:t>Alert wording</a:t>
-            </a:r>
-            <a:endParaRPr lang="en-US" sz="1350" dirty="0"/>
-          </a:p>
-        </p:txBody>
-      </p:sp>
-      <p:sp>
-        <p:nvSpPr>
-          <p:cNvPr id="22" name="Text 20"/>
-          <p:cNvSpPr txBox="1"/>
-          <p:nvPr/>
-        </p:nvSpPr>
-        <p:spPr>
-          <a:xfrm>
-            <a:off x="3429000" y="3520440"/>
-            <a:ext cx="2286000" cy="713232"/>
-          </a:xfrm>
-          <a:prstGeom prst="rect">
-            <a:avLst/>
-          </a:prstGeom>
-          <a:noFill/>
-          <a:ln/>
-        </p:spPr>
-        <p:txBody>
-          <a:bodyPr wrap="square" lIns="0" tIns="0" rIns="0" bIns="0" rtlCol="0" anchor="t"/>
-          <a:lstStyle/>
-          <a:p>
-            <a:pPr indent="0" marL="0">
-              <a:buNone/>
-            </a:pPr>
-            <a:r>
-              <a:rPr lang="en-US" sz="1150" dirty="0">
-                <a:solidFill>
-                  <a:srgbClr val="5B7780"/>
-                </a:solidFill>
-                <a:latin typeface="Calibri" pitchFamily="34" charset="0"/>
-                <a:ea typeface="Calibri" pitchFamily="34" charset="-122"/>
-                <a:cs typeface="Calibri" pitchFamily="34" charset="-120"/>
-              </a:rPr>
-              <a:t>Written only from computed numbers; the pharmacist sends it.</a:t>
-            </a:r>
-            <a:endParaRPr lang="en-US" sz="1150" dirty="0"/>
-          </a:p>
-        </p:txBody>
-      </p:sp>
-      <p:sp>
-        <p:nvSpPr>
-          <p:cNvPr id="23" name="Shape 21"/>
-          <p:cNvSpPr/>
-          <p:nvPr/>
-        </p:nvSpPr>
-        <p:spPr>
-          <a:xfrm>
-            <a:off x="6035040" y="2880360"/>
-            <a:ext cx="2606040" cy="1417320"/>
-          </a:xfrm>
-          <a:prstGeom prst="roundRect">
-            <a:avLst>
-              <a:gd name="adj" fmla="val 7742"/>
-            </a:avLst>
-          </a:prstGeom>
-          <a:solidFill>
-            <a:srgbClr val="FFFFFF"/>
-          </a:solidFill>
-          <a:ln w="9525">
-            <a:solidFill>
-              <a:srgbClr val="DCEBE7"/>
-            </a:solidFill>
-            <a:prstDash val="solid"/>
-          </a:ln>
-          <a:effectLst>
-            <a:outerShdw sx="100000" sy="100000" kx="0" ky="0" algn="bl" rotWithShape="0" blurRad="127000" dist="38100" dir="5400000">
-              <a:srgbClr val="14665C">
-                <a:alpha val="18000"/>
-              </a:srgbClr>
-            </a:outerShdw>
-          </a:effectLst>
-        </p:spPr>
-      </p:sp>
-      <p:sp>
-        <p:nvSpPr>
-          <p:cNvPr id="24" name="Shape 22"/>
-          <p:cNvSpPr/>
-          <p:nvPr/>
-        </p:nvSpPr>
-        <p:spPr>
-          <a:xfrm>
-            <a:off x="6217920" y="3063240"/>
-            <a:ext cx="310896" cy="310896"/>
-          </a:xfrm>
-          <a:prstGeom prst="ellipse">
-            <a:avLst/>
-          </a:prstGeom>
-          <a:solidFill>
-            <a:srgbClr val="0B3F39"/>
-          </a:solidFill>
-          <a:ln w="12700">
-            <a:solidFill>
-              <a:srgbClr val="0B3F39"/>
-            </a:solidFill>
-            <a:prstDash val="solid"/>
-          </a:ln>
-        </p:spPr>
-      </p:sp>
-      <p:sp>
-        <p:nvSpPr>
-          <p:cNvPr id="25" name="Text 23"/>
-          <p:cNvSpPr txBox="1"/>
-          <p:nvPr/>
-        </p:nvSpPr>
-        <p:spPr>
-          <a:xfrm>
-            <a:off x="6629400" y="3017520"/>
-            <a:ext cx="1874520" cy="411480"/>
-          </a:xfrm>
-          <a:prstGeom prst="rect">
-            <a:avLst/>
-          </a:prstGeom>
-          <a:noFill/>
-          <a:ln/>
-        </p:spPr>
-        <p:txBody>
-          <a:bodyPr wrap="square" lIns="0" tIns="0" rIns="0" bIns="0" rtlCol="0" anchor="ctr"/>
-          <a:lstStyle/>
-          <a:p>
-            <a:pPr indent="0" marL="0">
-              <a:buNone/>
-            </a:pPr>
-            <a:r>
-              <a:rPr lang="en-US" sz="1350" b="1" dirty="0">
-                <a:solidFill>
-                  <a:srgbClr val="16323A"/>
-                </a:solidFill>
-                <a:latin typeface="Cambria" pitchFamily="34" charset="0"/>
-                <a:ea typeface="Cambria" pitchFamily="34" charset="-122"/>
-                <a:cs typeface="Cambria" pitchFamily="34" charset="-120"/>
-              </a:rPr>
-              <a:t>Upload to DVDMS</a:t>
-            </a:r>
-            <a:endParaRPr lang="en-US" sz="1350" dirty="0"/>
-          </a:p>
-        </p:txBody>
-      </p:sp>
-      <p:sp>
-        <p:nvSpPr>
-          <p:cNvPr id="26" name="Text 24"/>
-          <p:cNvSpPr txBox="1"/>
-          <p:nvPr/>
-        </p:nvSpPr>
-        <p:spPr>
-          <a:xfrm>
-            <a:off x="6217920" y="3520440"/>
-            <a:ext cx="2286000" cy="713232"/>
-          </a:xfrm>
-          <a:prstGeom prst="rect">
-            <a:avLst/>
-          </a:prstGeom>
-          <a:noFill/>
-          <a:ln/>
-        </p:spPr>
-        <p:txBody>
-          <a:bodyPr wrap="square" lIns="0" tIns="0" rIns="0" bIns="0" rtlCol="0" anchor="t"/>
-          <a:lstStyle/>
-          <a:p>
-            <a:pPr indent="0" marL="0">
-              <a:buNone/>
-            </a:pPr>
-            <a:r>
-              <a:rPr lang="en-US" sz="1150" dirty="0">
-                <a:solidFill>
-                  <a:srgbClr val="5B7780"/>
-                </a:solidFill>
-                <a:latin typeface="Calibri" pitchFamily="34" charset="0"/>
-                <a:ea typeface="Calibri" pitchFamily="34" charset="-122"/>
-                <a:cs typeface="Calibri" pitchFamily="34" charset="-120"/>
-              </a:rPr>
-              <a:t>Never automatic: the file is downloaded and reviewed first.</a:t>
-            </a:r>
-            <a:endParaRPr lang="en-US" sz="1150" dirty="0"/>
+              <a:t>Safeguards: unsure cells yellow · balance errors red · batch cross-check · nothing uploaded automatically · officer approves every transfer.</a:t>
+            </a:r>
+            <a:endParaRPr lang="en-US" sz="1050" dirty="0"/>
           </a:p>
         </p:txBody>
       </p:sp>

</xml_diff>

<commit_message>
Real handwritten sample page, deck with real-page screenshots + PDF, README quick start with live link
Co-Authored-By: Claude Opus 5.5 <noreply@anthropic.com>
</commit_message>
<xml_diff>
--- a/docs/deck/Register-Lens-pitch-deck.pptx
+++ b/docs/deck/Register-Lens-pitch-deck.pptx
@@ -5456,7 +5456,7 @@
                 <a:ea typeface="Calibri" pitchFamily="34" charset="-122"/>
                 <a:cs typeface="Calibri" pitchFamily="34" charset="-120"/>
               </a:rPr>
-              <a:t>Barabanki: every DH, CHC, PHC and Health &amp; Wellness Centre at its real location, coloured by stock risk</a:t>
+              <a:t>Gonda: every facility at its real location, coloured by stock risk; purple = villages more than 8 km from a PHC/CHC (1,428 in Gonda)</a:t>
             </a:r>
             <a:endParaRPr lang="en-US" sz="1100" dirty="0"/>
           </a:p>
@@ -6772,7 +6772,7 @@
                 <a:ea typeface="Cambria" pitchFamily="34" charset="-122"/>
                 <a:cs typeface="Cambria" pitchFamily="34" charset="-120"/>
               </a:rPr>
-              <a:t>The working prototype</a:t>
+              <a:t>A real handwritten page, end to end</a:t>
             </a:r>
             <a:endParaRPr lang="en-US" sz="3000" dirty="0"/>
           </a:p>
@@ -6788,14 +6788,13 @@
         </p:nvPicPr>
         <p:blipFill>
           <a:blip r:embed="rId1"/>
-          <a:stretch>
-            <a:fillRect/>
-          </a:stretch>
+          <a:srcRect l="0" r="0" t="0" b="0"/>
+          <a:stretch/>
         </p:blipFill>
         <p:spPr>
           <a:xfrm>
             <a:off x="457200" y="1280160"/>
-            <a:ext cx="2606040" cy="1293876"/>
+            <a:ext cx="2606040" cy="1463040"/>
           </a:xfrm>
           <a:prstGeom prst="rect">
             <a:avLst/>
@@ -6817,7 +6816,7 @@
         </p:nvSpPr>
         <p:spPr>
           <a:xfrm>
-            <a:off x="457200" y="2697480"/>
+            <a:off x="457200" y="2816352"/>
             <a:ext cx="2606040" cy="365760"/>
           </a:xfrm>
           <a:prstGeom prst="rect">
@@ -6842,7 +6841,7 @@
                 <a:ea typeface="Calibri" pitchFamily="34" charset="-122"/>
                 <a:cs typeface="Calibri" pitchFamily="34" charset="-120"/>
               </a:rPr>
-              <a:t>Review: flagged lines with reasons</a:t>
+              <a:t>Review: the wrong Zinc total is caught in red</a:t>
             </a:r>
             <a:endParaRPr lang="en-US" sz="1200" dirty="0"/>
           </a:p>
@@ -6858,14 +6857,13 @@
         </p:nvPicPr>
         <p:blipFill>
           <a:blip r:embed="rId2"/>
-          <a:stretch>
-            <a:fillRect/>
-          </a:stretch>
+          <a:srcRect l="0" r="0" t="0" b="0"/>
+          <a:stretch/>
         </p:blipFill>
         <p:spPr>
           <a:xfrm>
             <a:off x="3246120" y="1280160"/>
-            <a:ext cx="2606040" cy="1293876"/>
+            <a:ext cx="2606040" cy="1463040"/>
           </a:xfrm>
           <a:prstGeom prst="rect">
             <a:avLst/>
@@ -6887,7 +6885,7 @@
         </p:nvSpPr>
         <p:spPr>
           <a:xfrm>
-            <a:off x="3246120" y="2697480"/>
+            <a:off x="3246120" y="2816352"/>
             <a:ext cx="2606040" cy="365760"/>
           </a:xfrm>
           <a:prstGeom prst="rect">
@@ -6912,7 +6910,7 @@
                 <a:ea typeface="Calibri" pitchFamily="34" charset="-122"/>
                 <a:cs typeface="Calibri" pitchFamily="34" charset="-120"/>
               </a:rPr>
-              <a:t>Reconcile: DVDMS vs the register</a:t>
+              <a:t>Compare: register vs DVDMS days of stock</a:t>
             </a:r>
             <a:endParaRPr lang="en-US" sz="1200" dirty="0"/>
           </a:p>
@@ -6928,14 +6926,13 @@
         </p:nvPicPr>
         <p:blipFill>
           <a:blip r:embed="rId3"/>
-          <a:stretch>
-            <a:fillRect/>
-          </a:stretch>
+          <a:srcRect l="0" r="0" t="0" b="0"/>
+          <a:stretch/>
         </p:blipFill>
         <p:spPr>
           <a:xfrm>
             <a:off x="6035040" y="1280160"/>
-            <a:ext cx="2606040" cy="1293876"/>
+            <a:ext cx="2606040" cy="1463040"/>
           </a:xfrm>
           <a:prstGeom prst="rect">
             <a:avLst/>
@@ -6957,7 +6954,7 @@
         </p:nvSpPr>
         <p:spPr>
           <a:xfrm>
-            <a:off x="6035040" y="2697480"/>
+            <a:off x="6035040" y="2816352"/>
             <a:ext cx="2606040" cy="365760"/>
           </a:xfrm>
           <a:prstGeom prst="rect">
@@ -6982,7 +6979,7 @@
                 <a:ea typeface="Calibri" pitchFamily="34" charset="-122"/>
                 <a:cs typeface="Calibri" pitchFamily="34" charset="-120"/>
               </a:rPr>
-              <a:t>Sync: bulk entry + Hindi/English alert</a:t>
+              <a:t>Sync: DVDMS entry + alert in Urdu, Hindi, English</a:t>
             </a:r>
             <a:endParaRPr lang="en-US" sz="1200" dirty="0"/>
           </a:p>
@@ -7035,7 +7032,7 @@
                 <a:ea typeface="Calibri" pitchFamily="34" charset="-122"/>
                 <a:cs typeface="Calibri" pitchFamily="34" charset="-120"/>
               </a:rPr>
-              <a:t>photo upload or sample page, image clean-up, Gemini read, review, reconcile, Excel export, Hindi/English alert, district view.</a:t>
+              <a:t>our own handwritten page in Hindi + English, with Hindi numerals and a crossed-out value. Gemini read all 10 lines correctly, the planted Zinc error was caught, and 54 → 45 was understood as a correction.</a:t>
             </a:r>
             <a:endParaRPr lang="en-US" sz="1400" dirty="0"/>
           </a:p>
@@ -7074,7 +7071,7 @@
                 <a:ea typeface="Calibri" pitchFamily="34" charset="-122"/>
                 <a:cs typeface="Calibri" pitchFamily="34" charset="-120"/>
               </a:rPr>
-              <a:t>React + FastAPI + Gemini API · built for a PC browser first</a:t>
+              <a:t>React + FastAPI + Gemini API on Cloud Run · works on PC and as an installable phone app</a:t>
             </a:r>
             <a:endParaRPr lang="en-US" sz="1100" dirty="0"/>
           </a:p>

</xml_diff>